<commit_message>
Added program dropdown and updated font size
</commit_message>
<xml_diff>
--- a/shubh.pptx
+++ b/shubh.pptx
@@ -365,7 +365,7 @@
           <a:p>
             <a:fld id="{C512A3C6-5DC9-4A56-9651-5479ABF6CC04}" type="datetimeFigureOut">
               <a:rPr lang="en-US" smtClean="0"/>
-              <a:t>2/10/2026</a:t>
+              <a:t>3/4/2026</a:t>
             </a:fld>
             <a:endParaRPr lang="en-US"/>
           </a:p>
@@ -530,7 +530,7 @@
           <a:p>
             <a:fld id="{EF9B4179-EA0F-480E-B68E-FD4684AB3DB5}" type="datetimeFigureOut">
               <a:rPr lang="en-IN" smtClean="0"/>
-              <a:t>10-02-2026</a:t>
+              <a:t>04-03-2026</a:t>
             </a:fld>
             <a:endParaRPr lang="en-IN"/>
           </a:p>
@@ -911,7 +911,7 @@
                   </a:prstClr>
                 </a:solidFill>
               </a:rPr>
-              <a:t>2/10/2026</a:t>
+              <a:t>3/4/2026</a:t>
             </a:fld>
             <a:endParaRPr lang="en-US">
               <a:solidFill>
@@ -1140,7 +1140,7 @@
                   </a:prstClr>
                 </a:solidFill>
               </a:rPr>
-              <a:t>2/10/2026</a:t>
+              <a:t>3/4/2026</a:t>
             </a:fld>
             <a:endParaRPr lang="en-US">
               <a:solidFill>
@@ -1423,7 +1423,7 @@
                   </a:prstClr>
                 </a:solidFill>
               </a:rPr>
-              <a:t>2/10/2026</a:t>
+              <a:t>3/4/2026</a:t>
             </a:fld>
             <a:endParaRPr lang="en-US">
               <a:solidFill>
@@ -1626,7 +1626,7 @@
                   </a:prstClr>
                 </a:solidFill>
               </a:rPr>
-              <a:t>2/10/2026</a:t>
+              <a:t>3/4/2026</a:t>
             </a:fld>
             <a:endParaRPr lang="en-US">
               <a:solidFill>
@@ -1795,7 +1795,7 @@
                   </a:prstClr>
                 </a:solidFill>
               </a:rPr>
-              <a:t>2/10/2026</a:t>
+              <a:t>3/4/2026</a:t>
             </a:fld>
             <a:endParaRPr lang="en-US">
               <a:solidFill>
@@ -2088,7 +2088,7 @@
                   </a:prstClr>
                 </a:solidFill>
               </a:rPr>
-              <a:t>2/10/2026</a:t>
+              <a:t>3/4/2026</a:t>
             </a:fld>
             <a:endParaRPr lang="en-US" sz="1705">
               <a:solidFill>
@@ -2340,7 +2340,7 @@
         <p:spPr>
           <a:xfrm>
             <a:off x="818005" y="211649"/>
-            <a:ext cx="5928428" cy="239201"/>
+            <a:ext cx="5928428" cy="466315"/>
           </a:xfrm>
           <a:prstGeom prst="rect">
             <a:avLst/>
@@ -2365,19 +2365,26 @@
               <a:t>Program</a:t>
             </a:r>
             <a:r>
-              <a:rPr dirty="0">
+              <a:rPr>
                 <a:latin typeface="Segoe UI" panose="020B0502040204020203" pitchFamily="34" charset="0"/>
                 <a:cs typeface="Segoe UI" panose="020B0502040204020203" pitchFamily="34" charset="0"/>
               </a:rPr>
-              <a:t> : </a:t>
+              <a:t> :</a:t>
             </a:r>
             <a:r>
-              <a:rPr lang="en-US" spc="-5" dirty="0">
+              <a:rPr lang="en-US">
                 <a:latin typeface="Segoe UI" panose="020B0502040204020203" pitchFamily="34" charset="0"/>
                 <a:cs typeface="Segoe UI" panose="020B0502040204020203" pitchFamily="34" charset="0"/>
               </a:rPr>
-              <a:t>Computer Engineering  </a:t>
+              <a:t> </a:t>
             </a:r>
+            <a:r>
+              <a:rPr lang="en-US"/>
+              <a:t>{{PROGRAM_NAME}} </a:t>
+            </a:r>
+            <a:br>
+              <a:rPr lang="en-US"/>
+            </a:br>
             <a:endParaRPr spc="-15" dirty="0">
               <a:latin typeface="Segoe UI" panose="020B0502040204020203" pitchFamily="34" charset="0"/>
               <a:cs typeface="Segoe UI" panose="020B0502040204020203" pitchFamily="34" charset="0"/>

</xml_diff>